<commit_message>
Reviews, Settings, Billing and dashboard updates
- Reviews: compact two-column owner Reviews page, reply edit/delete icons with
  confirm dialog, review photo upload removed (web, mobile, API)
- Settings: left-nav layout with sections, sticky save bar, unsaved-changes
  warning, new Account & security section with change-password API
- Billing: GST no longer charged on new bills (old bills keep their data),
  refund button removed from invoice page, compact one-row filters
- Dashboard: stat card spacing and responsive columns, removed fixed width caps
- Explore: removed account block from hero, hid category scrollbar

Co-Authored-By: Claude Sonnet 5.5 <noreply@anthropic.com>
</commit_message>
<xml_diff>
--- a/presentation/Galora_Presentation.pptx
+++ b/presentation/Galora_Presentation.pptx
@@ -123,12 +123,12 @@
   <p:extLst>
     <p:ext uri="{521415D9-36F7-43E2-AB2F-B90AF26B5E84}">
       <p14:sectionLst xmlns:p14="http://schemas.microsoft.com/office/powerpoint/2010/main">
-        <p14:section name="Opening" id="{0a8a3e64-1a8c-ad6e-94ea-500aa8ea224f}">
+        <p14:section name="Opening" id="{0d829047-f06e-59ab-c75b-4ffef05b3634}">
           <p14:sldIdLst>
             <p14:sldId id="256"/>
           </p14:sldIdLst>
         </p14:section>
-        <p14:section name="Problem and Goals" id="{fa70e7c0-ab99-693f-f93c-13b9cac52348}">
+        <p14:section name="Problem and Goals" id="{be5e88c4-d87c-6cc5-be0e-a42456ace614}">
           <p14:sldIdLst>
             <p14:sldId id="257"/>
             <p14:sldId id="258"/>
@@ -136,7 +136,7 @@
             <p14:sldId id="260"/>
           </p14:sldIdLst>
         </p14:section>
-        <p14:section name="Features and Roles" id="{94641a57-bbbe-fd7c-7785-a2e50255d60b}">
+        <p14:section name="Features and Roles" id="{83e918aa-7878-40bd-8ba0-959f97356060}">
           <p14:sldIdLst>
             <p14:sldId id="261"/>
             <p14:sldId id="262"/>
@@ -144,7 +144,7 @@
             <p14:sldId id="264"/>
           </p14:sldIdLst>
         </p14:section>
-        <p14:section name="Technology and Design" id="{56361a6f-da19-b175-85ff-1f69c2cf8b82}">
+        <p14:section name="Technology and Design" id="{e7d73742-af6f-a952-011e-85766f200261}">
           <p14:sldIdLst>
             <p14:sldId id="265"/>
             <p14:sldId id="266"/>
@@ -152,7 +152,7 @@
             <p14:sldId id="268"/>
           </p14:sldIdLst>
         </p14:section>
-        <p14:section name="Product and Outlook" id="{4e3fb2be-ee6c-1029-363d-467f2c07f981}">
+        <p14:section name="Product and Outlook" id="{a964846e-f8d6-0814-b7fb-9981c6678311}">
           <p14:sldIdLst>
             <p14:sldId id="269"/>
             <p14:sldId id="270"/>
@@ -566,7 +566,6 @@
               <a:rPr lang="en-US" dirty="0"/>
               <a:t>SLIDE 1 - Title
 Kya bolna hai: "Good morning sir/ma'am. Mera project hai Galora, jo ek Salon Management aur Customer Booking Platform hai. Isme salon owner apna poora salon manage karta hai aur customer online booking karta hai."
-Tip: Apna naam, college, guide ka naam aur academic year placeholders ki jagah likh lena (slide 1 aur slide 17).
 Ek line me project: "Galora = salon ka digital manager + customers ke liye booking app."</a:t>
             </a:r>
             <a:endParaRPr lang="en-US" dirty="0"/>
@@ -2845,96 +2844,6 @@
           </a:p>
         </p:txBody>
       </p:sp>
-      <p:sp>
-        <p:nvSpPr>
-          <p:cNvPr id="8" name="Text 4"/>
-          <p:cNvSpPr txBox="1"/>
-          <p:nvPr/>
-        </p:nvSpPr>
-        <p:spPr>
-          <a:xfrm>
-            <a:off x="731520" y="4754880"/>
-            <a:ext cx="6400800" cy="1280160"/>
-          </a:xfrm>
-          <a:prstGeom prst="rect">
-            <a:avLst/>
-          </a:prstGeom>
-          <a:noFill/>
-          <a:ln/>
-        </p:spPr>
-        <p:txBody>
-          <a:bodyPr wrap="square" lIns="0" tIns="0" rIns="0" bIns="0" rtlCol="0" anchor="t"/>
-          <a:lstStyle/>
-          <a:p>
-            <a:pPr indent="0" marL="0">
-              <a:spcAft>
-                <a:spcPts val="400"/>
-              </a:spcAft>
-              <a:buNone/>
-            </a:pPr>
-            <a:r>
-              <a:rPr lang="en-US" sz="1600" b="1" dirty="0">
-                <a:solidFill>
-                  <a:schemeClr val="accent1"/>
-                </a:solidFill>
-              </a:rPr>
-              <a:t>College Project Presentation</a:t>
-            </a:r>
-            <a:endParaRPr lang="en-US" sz="1600" dirty="0"/>
-          </a:p>
-          <a:p>
-            <a:pPr indent="0" marL="0">
-              <a:spcAft>
-                <a:spcPts val="400"/>
-              </a:spcAft>
-              <a:buNone/>
-            </a:pPr>
-            <a:r>
-              <a:rPr lang="en-US" sz="1600" dirty="0">
-                <a:solidFill>
-                  <a:schemeClr val="accent6"/>
-                </a:solidFill>
-              </a:rPr>
-              <a:t>Presented by: [Student Name]</a:t>
-            </a:r>
-            <a:endParaRPr lang="en-US" sz="1600" dirty="0"/>
-          </a:p>
-          <a:p>
-            <a:pPr indent="0" marL="0">
-              <a:spcAft>
-                <a:spcPts val="400"/>
-              </a:spcAft>
-              <a:buNone/>
-            </a:pPr>
-            <a:r>
-              <a:rPr lang="en-US" sz="1600" dirty="0">
-                <a:solidFill>
-                  <a:schemeClr val="accent6"/>
-                </a:solidFill>
-              </a:rPr>
-              <a:t>College: [College Name]   |   Guide: [Guide Name]</a:t>
-            </a:r>
-            <a:endParaRPr lang="en-US" sz="1600" dirty="0"/>
-          </a:p>
-          <a:p>
-            <a:pPr indent="0" marL="0">
-              <a:spcAft>
-                <a:spcPts val="400"/>
-              </a:spcAft>
-              <a:buNone/>
-            </a:pPr>
-            <a:r>
-              <a:rPr lang="en-US" sz="1600" dirty="0">
-                <a:solidFill>
-                  <a:schemeClr val="accent6"/>
-                </a:solidFill>
-              </a:rPr>
-              <a:t>Academic year: [Academic Year]</a:t>
-            </a:r>
-            <a:endParaRPr lang="en-US" sz="1600" dirty="0"/>
-          </a:p>
-        </p:txBody>
-      </p:sp>
     </p:spTree>
   </p:cSld>
   <p:clrMapOvr>
@@ -9216,63 +9125,7 @@
       </p:sp>
       <p:sp>
         <p:nvSpPr>
-          <p:cNvPr id="5" name="Text 2"/>
-          <p:cNvSpPr txBox="1"/>
-          <p:nvPr/>
-        </p:nvSpPr>
-        <p:spPr>
-          <a:xfrm>
-            <a:off x="731520" y="4754880"/>
-            <a:ext cx="6400800" cy="822960"/>
-          </a:xfrm>
-          <a:prstGeom prst="rect">
-            <a:avLst/>
-          </a:prstGeom>
-          <a:noFill/>
-          <a:ln/>
-        </p:spPr>
-        <p:txBody>
-          <a:bodyPr wrap="square" lIns="0" tIns="0" rIns="0" bIns="0" rtlCol="0" anchor="t"/>
-          <a:lstStyle/>
-          <a:p>
-            <a:pPr indent="0" marL="0">
-              <a:spcAft>
-                <a:spcPts val="400"/>
-              </a:spcAft>
-              <a:buNone/>
-            </a:pPr>
-            <a:r>
-              <a:rPr lang="en-US" sz="1600" dirty="0">
-                <a:solidFill>
-                  <a:schemeClr val="accent6"/>
-                </a:solidFill>
-              </a:rPr>
-              <a:t>[Student Name]  |  [College Name]</a:t>
-            </a:r>
-            <a:endParaRPr lang="en-US" sz="1600" dirty="0"/>
-          </a:p>
-          <a:p>
-            <a:pPr indent="0" marL="0">
-              <a:spcAft>
-                <a:spcPts val="400"/>
-              </a:spcAft>
-              <a:buNone/>
-            </a:pPr>
-            <a:r>
-              <a:rPr lang="en-US" sz="1600" dirty="0">
-                <a:solidFill>
-                  <a:schemeClr val="accent6"/>
-                </a:solidFill>
-              </a:rPr>
-              <a:t>Guide: [Guide Name]  |  [Academic Year]</a:t>
-            </a:r>
-            <a:endParaRPr lang="en-US" sz="1600" dirty="0"/>
-          </a:p>
-        </p:txBody>
-      </p:sp>
-      <p:sp>
-        <p:nvSpPr>
-          <p:cNvPr id="6" name="Icon circle FaCut"/>
+          <p:cNvPr id="5" name="Icon circle FaCut"/>
           <p:cNvSpPr/>
           <p:nvPr/>
         </p:nvSpPr>
@@ -9297,7 +9150,7 @@
       </p:sp>
       <p:pic>
         <p:nvPicPr>
-          <p:cNvPr id="7" name="Image 1" descr="Cut icon">    </p:cNvPr>
+          <p:cNvPr id="6" name="Image 1" descr="Cut icon">    </p:cNvPr>
           <p:cNvPicPr>
             <a:picLocks noChangeAspect="1"/>
           </p:cNvPicPr>
@@ -9321,7 +9174,7 @@
       </p:pic>
       <p:sp>
         <p:nvSpPr>
-          <p:cNvPr id="8" name="Text 4"/>
+          <p:cNvPr id="7" name="Text 3"/>
           <p:cNvSpPr txBox="1"/>
           <p:nvPr/>
         </p:nvSpPr>

</xml_diff>